<commit_message>
making some more figures
</commit_message>
<xml_diff>
--- a/data/data_analysis/CAGR_plots.pptx
+++ b/data/data_analysis/CAGR_plots.pptx
@@ -9,6 +9,9 @@
     <p:sldId id="257" r:id="rId3"/>
     <p:sldId id="258" r:id="rId4"/>
     <p:sldId id="259" r:id="rId5"/>
+    <p:sldId id="260" r:id="rId6"/>
+    <p:sldId id="261" r:id="rId7"/>
+    <p:sldId id="262" r:id="rId8"/>
   </p:sldIdLst>
   <p:sldSz cx="12192000" cy="6858000"/>
   <p:notesSz cx="6858000" cy="9144000"/>
@@ -262,7 +265,7 @@
           <a:p>
             <a:fld id="{25C820A4-0B52-43A8-957A-6471D3E9C03A}" type="datetimeFigureOut">
               <a:rPr lang="en-US" smtClean="0"/>
-              <a:t>7/10/2026</a:t>
+              <a:t>7/14/2026</a:t>
             </a:fld>
             <a:endParaRPr lang="en-US"/>
           </a:p>
@@ -460,7 +463,7 @@
           <a:p>
             <a:fld id="{25C820A4-0B52-43A8-957A-6471D3E9C03A}" type="datetimeFigureOut">
               <a:rPr lang="en-US" smtClean="0"/>
-              <a:t>7/10/2026</a:t>
+              <a:t>7/14/2026</a:t>
             </a:fld>
             <a:endParaRPr lang="en-US"/>
           </a:p>
@@ -668,7 +671,7 @@
           <a:p>
             <a:fld id="{25C820A4-0B52-43A8-957A-6471D3E9C03A}" type="datetimeFigureOut">
               <a:rPr lang="en-US" smtClean="0"/>
-              <a:t>7/10/2026</a:t>
+              <a:t>7/14/2026</a:t>
             </a:fld>
             <a:endParaRPr lang="en-US"/>
           </a:p>
@@ -866,7 +869,7 @@
           <a:p>
             <a:fld id="{25C820A4-0B52-43A8-957A-6471D3E9C03A}" type="datetimeFigureOut">
               <a:rPr lang="en-US" smtClean="0"/>
-              <a:t>7/10/2026</a:t>
+              <a:t>7/14/2026</a:t>
             </a:fld>
             <a:endParaRPr lang="en-US"/>
           </a:p>
@@ -1141,7 +1144,7 @@
           <a:p>
             <a:fld id="{25C820A4-0B52-43A8-957A-6471D3E9C03A}" type="datetimeFigureOut">
               <a:rPr lang="en-US" smtClean="0"/>
-              <a:t>7/10/2026</a:t>
+              <a:t>7/14/2026</a:t>
             </a:fld>
             <a:endParaRPr lang="en-US"/>
           </a:p>
@@ -1406,7 +1409,7 @@
           <a:p>
             <a:fld id="{25C820A4-0B52-43A8-957A-6471D3E9C03A}" type="datetimeFigureOut">
               <a:rPr lang="en-US" smtClean="0"/>
-              <a:t>7/10/2026</a:t>
+              <a:t>7/14/2026</a:t>
             </a:fld>
             <a:endParaRPr lang="en-US"/>
           </a:p>
@@ -1818,7 +1821,7 @@
           <a:p>
             <a:fld id="{25C820A4-0B52-43A8-957A-6471D3E9C03A}" type="datetimeFigureOut">
               <a:rPr lang="en-US" smtClean="0"/>
-              <a:t>7/10/2026</a:t>
+              <a:t>7/14/2026</a:t>
             </a:fld>
             <a:endParaRPr lang="en-US"/>
           </a:p>
@@ -1959,7 +1962,7 @@
           <a:p>
             <a:fld id="{25C820A4-0B52-43A8-957A-6471D3E9C03A}" type="datetimeFigureOut">
               <a:rPr lang="en-US" smtClean="0"/>
-              <a:t>7/10/2026</a:t>
+              <a:t>7/14/2026</a:t>
             </a:fld>
             <a:endParaRPr lang="en-US"/>
           </a:p>
@@ -2072,7 +2075,7 @@
           <a:p>
             <a:fld id="{25C820A4-0B52-43A8-957A-6471D3E9C03A}" type="datetimeFigureOut">
               <a:rPr lang="en-US" smtClean="0"/>
-              <a:t>7/10/2026</a:t>
+              <a:t>7/14/2026</a:t>
             </a:fld>
             <a:endParaRPr lang="en-US"/>
           </a:p>
@@ -2383,7 +2386,7 @@
           <a:p>
             <a:fld id="{25C820A4-0B52-43A8-957A-6471D3E9C03A}" type="datetimeFigureOut">
               <a:rPr lang="en-US" smtClean="0"/>
-              <a:t>7/10/2026</a:t>
+              <a:t>7/14/2026</a:t>
             </a:fld>
             <a:endParaRPr lang="en-US"/>
           </a:p>
@@ -2671,7 +2674,7 @@
           <a:p>
             <a:fld id="{25C820A4-0B52-43A8-957A-6471D3E9C03A}" type="datetimeFigureOut">
               <a:rPr lang="en-US" smtClean="0"/>
-              <a:t>7/10/2026</a:t>
+              <a:t>7/14/2026</a:t>
             </a:fld>
             <a:endParaRPr lang="en-US"/>
           </a:p>
@@ -2912,7 +2915,7 @@
           <a:p>
             <a:fld id="{25C820A4-0B52-43A8-957A-6471D3E9C03A}" type="datetimeFigureOut">
               <a:rPr lang="en-US" smtClean="0"/>
-              <a:t>7/10/2026</a:t>
+              <a:t>7/14/2026</a:t>
             </a:fld>
             <a:endParaRPr lang="en-US"/>
           </a:p>
@@ -3672,6 +3675,294 @@
 </p:sld>
 </file>
 
+<file path=ppt/slides/slide5.xml><?xml version="1.0" encoding="utf-8"?>
+<p:sld xmlns:a="http://schemas.openxmlformats.org/drawingml/2006/main" xmlns:r="http://schemas.openxmlformats.org/officeDocument/2006/relationships" xmlns:p="http://schemas.openxmlformats.org/presentationml/2006/main">
+  <p:cSld>
+    <p:spTree>
+      <p:nvGrpSpPr>
+        <p:cNvPr id="1" name="">
+          <a:extLst>
+            <a:ext uri="{FF2B5EF4-FFF2-40B4-BE49-F238E27FC236}">
+              <a16:creationId xmlns:a16="http://schemas.microsoft.com/office/drawing/2014/main" id="{C77F5F33-99CA-0504-6C3C-DB72A8328C11}"/>
+            </a:ext>
+          </a:extLst>
+        </p:cNvPr>
+        <p:cNvGrpSpPr/>
+        <p:nvPr/>
+      </p:nvGrpSpPr>
+      <p:grpSpPr>
+        <a:xfrm>
+          <a:off x="0" y="0"/>
+          <a:ext cx="0" cy="0"/>
+          <a:chOff x="0" y="0"/>
+          <a:chExt cx="0" cy="0"/>
+        </a:xfrm>
+      </p:grpSpPr>
+      <p:pic>
+        <p:nvPicPr>
+          <p:cNvPr id="4" name="Picture 3">
+            <a:extLst>
+              <a:ext uri="{FF2B5EF4-FFF2-40B4-BE49-F238E27FC236}">
+                <a16:creationId xmlns:a16="http://schemas.microsoft.com/office/drawing/2014/main" id="{CC86A5D1-DE65-90C0-D7DC-5479E1645CF8}"/>
+              </a:ext>
+            </a:extLst>
+          </p:cNvPr>
+          <p:cNvPicPr>
+            <a:picLocks noChangeAspect="1"/>
+          </p:cNvPicPr>
+          <p:nvPr/>
+        </p:nvPicPr>
+        <p:blipFill>
+          <a:blip r:embed="rId2"/>
+          <a:stretch>
+            <a:fillRect/>
+          </a:stretch>
+        </p:blipFill>
+        <p:spPr>
+          <a:xfrm>
+            <a:off x="0" y="0"/>
+            <a:ext cx="4134427" cy="2448267"/>
+          </a:xfrm>
+          <a:prstGeom prst="rect">
+            <a:avLst/>
+          </a:prstGeom>
+        </p:spPr>
+      </p:pic>
+      <p:pic>
+        <p:nvPicPr>
+          <p:cNvPr id="3" name="Picture 2">
+            <a:extLst>
+              <a:ext uri="{FF2B5EF4-FFF2-40B4-BE49-F238E27FC236}">
+                <a16:creationId xmlns:a16="http://schemas.microsoft.com/office/drawing/2014/main" id="{ED932843-C86B-DF5E-AE79-028E821BC5F0}"/>
+              </a:ext>
+            </a:extLst>
+          </p:cNvPr>
+          <p:cNvPicPr>
+            <a:picLocks noChangeAspect="1"/>
+          </p:cNvPicPr>
+          <p:nvPr/>
+        </p:nvPicPr>
+        <p:blipFill>
+          <a:blip r:embed="rId3"/>
+          <a:stretch>
+            <a:fillRect/>
+          </a:stretch>
+        </p:blipFill>
+        <p:spPr>
+          <a:xfrm>
+            <a:off x="717458" y="83079"/>
+            <a:ext cx="1028844" cy="1095528"/>
+          </a:xfrm>
+          <a:prstGeom prst="rect">
+            <a:avLst/>
+          </a:prstGeom>
+        </p:spPr>
+      </p:pic>
+    </p:spTree>
+    <p:extLst>
+      <p:ext uri="{BB962C8B-B14F-4D97-AF65-F5344CB8AC3E}">
+        <p14:creationId xmlns:p14="http://schemas.microsoft.com/office/powerpoint/2010/main" val="540003396"/>
+      </p:ext>
+    </p:extLst>
+  </p:cSld>
+  <p:clrMapOvr>
+    <a:masterClrMapping/>
+  </p:clrMapOvr>
+</p:sld>
+</file>
+
+<file path=ppt/slides/slide6.xml><?xml version="1.0" encoding="utf-8"?>
+<p:sld xmlns:a="http://schemas.openxmlformats.org/drawingml/2006/main" xmlns:r="http://schemas.openxmlformats.org/officeDocument/2006/relationships" xmlns:p="http://schemas.openxmlformats.org/presentationml/2006/main">
+  <p:cSld>
+    <p:spTree>
+      <p:nvGrpSpPr>
+        <p:cNvPr id="1" name="">
+          <a:extLst>
+            <a:ext uri="{FF2B5EF4-FFF2-40B4-BE49-F238E27FC236}">
+              <a16:creationId xmlns:a16="http://schemas.microsoft.com/office/drawing/2014/main" id="{8C6FEF73-1922-7278-C955-6DB4EFF50B4A}"/>
+            </a:ext>
+          </a:extLst>
+        </p:cNvPr>
+        <p:cNvGrpSpPr/>
+        <p:nvPr/>
+      </p:nvGrpSpPr>
+      <p:grpSpPr>
+        <a:xfrm>
+          <a:off x="0" y="0"/>
+          <a:ext cx="0" cy="0"/>
+          <a:chOff x="0" y="0"/>
+          <a:chExt cx="0" cy="0"/>
+        </a:xfrm>
+      </p:grpSpPr>
+      <p:pic>
+        <p:nvPicPr>
+          <p:cNvPr id="5" name="Picture 4">
+            <a:extLst>
+              <a:ext uri="{FF2B5EF4-FFF2-40B4-BE49-F238E27FC236}">
+                <a16:creationId xmlns:a16="http://schemas.microsoft.com/office/drawing/2014/main" id="{BDABBD13-13B0-D4D0-4813-20243B88A533}"/>
+              </a:ext>
+            </a:extLst>
+          </p:cNvPr>
+          <p:cNvPicPr>
+            <a:picLocks noChangeAspect="1"/>
+          </p:cNvPicPr>
+          <p:nvPr/>
+        </p:nvPicPr>
+        <p:blipFill>
+          <a:blip r:embed="rId2"/>
+          <a:stretch>
+            <a:fillRect/>
+          </a:stretch>
+        </p:blipFill>
+        <p:spPr>
+          <a:xfrm>
+            <a:off x="0" y="0"/>
+            <a:ext cx="4191585" cy="2467319"/>
+          </a:xfrm>
+          <a:prstGeom prst="rect">
+            <a:avLst/>
+          </a:prstGeom>
+        </p:spPr>
+      </p:pic>
+      <p:pic>
+        <p:nvPicPr>
+          <p:cNvPr id="3" name="Picture 2">
+            <a:extLst>
+              <a:ext uri="{FF2B5EF4-FFF2-40B4-BE49-F238E27FC236}">
+                <a16:creationId xmlns:a16="http://schemas.microsoft.com/office/drawing/2014/main" id="{86701E4D-E057-AE0E-C9B3-14DAC58DF00B}"/>
+              </a:ext>
+            </a:extLst>
+          </p:cNvPr>
+          <p:cNvPicPr>
+            <a:picLocks noChangeAspect="1"/>
+          </p:cNvPicPr>
+          <p:nvPr/>
+        </p:nvPicPr>
+        <p:blipFill>
+          <a:blip r:embed="rId3"/>
+          <a:stretch>
+            <a:fillRect/>
+          </a:stretch>
+        </p:blipFill>
+        <p:spPr>
+          <a:xfrm>
+            <a:off x="1752174" y="1094481"/>
+            <a:ext cx="1028844" cy="1095528"/>
+          </a:xfrm>
+          <a:prstGeom prst="rect">
+            <a:avLst/>
+          </a:prstGeom>
+        </p:spPr>
+      </p:pic>
+    </p:spTree>
+    <p:extLst>
+      <p:ext uri="{BB962C8B-B14F-4D97-AF65-F5344CB8AC3E}">
+        <p14:creationId xmlns:p14="http://schemas.microsoft.com/office/powerpoint/2010/main" val="4215283851"/>
+      </p:ext>
+    </p:extLst>
+  </p:cSld>
+  <p:clrMapOvr>
+    <a:masterClrMapping/>
+  </p:clrMapOvr>
+</p:sld>
+</file>
+
+<file path=ppt/slides/slide7.xml><?xml version="1.0" encoding="utf-8"?>
+<p:sld xmlns:a="http://schemas.openxmlformats.org/drawingml/2006/main" xmlns:r="http://schemas.openxmlformats.org/officeDocument/2006/relationships" xmlns:p="http://schemas.openxmlformats.org/presentationml/2006/main">
+  <p:cSld>
+    <p:spTree>
+      <p:nvGrpSpPr>
+        <p:cNvPr id="1" name="">
+          <a:extLst>
+            <a:ext uri="{FF2B5EF4-FFF2-40B4-BE49-F238E27FC236}">
+              <a16:creationId xmlns:a16="http://schemas.microsoft.com/office/drawing/2014/main" id="{6257E926-2845-1250-79EC-AC96511F0326}"/>
+            </a:ext>
+          </a:extLst>
+        </p:cNvPr>
+        <p:cNvGrpSpPr/>
+        <p:nvPr/>
+      </p:nvGrpSpPr>
+      <p:grpSpPr>
+        <a:xfrm>
+          <a:off x="0" y="0"/>
+          <a:ext cx="0" cy="0"/>
+          <a:chOff x="0" y="0"/>
+          <a:chExt cx="0" cy="0"/>
+        </a:xfrm>
+      </p:grpSpPr>
+      <p:pic>
+        <p:nvPicPr>
+          <p:cNvPr id="4" name="Picture 3">
+            <a:extLst>
+              <a:ext uri="{FF2B5EF4-FFF2-40B4-BE49-F238E27FC236}">
+                <a16:creationId xmlns:a16="http://schemas.microsoft.com/office/drawing/2014/main" id="{3A206368-5DAB-3AC9-23AD-1D923C8F650B}"/>
+              </a:ext>
+            </a:extLst>
+          </p:cNvPr>
+          <p:cNvPicPr>
+            <a:picLocks noChangeAspect="1"/>
+          </p:cNvPicPr>
+          <p:nvPr/>
+        </p:nvPicPr>
+        <p:blipFill>
+          <a:blip r:embed="rId2"/>
+          <a:stretch>
+            <a:fillRect/>
+          </a:stretch>
+        </p:blipFill>
+        <p:spPr>
+          <a:xfrm>
+            <a:off x="0" y="0"/>
+            <a:ext cx="4172532" cy="2486372"/>
+          </a:xfrm>
+          <a:prstGeom prst="rect">
+            <a:avLst/>
+          </a:prstGeom>
+        </p:spPr>
+      </p:pic>
+      <p:pic>
+        <p:nvPicPr>
+          <p:cNvPr id="7" name="Picture 6">
+            <a:extLst>
+              <a:ext uri="{FF2B5EF4-FFF2-40B4-BE49-F238E27FC236}">
+                <a16:creationId xmlns:a16="http://schemas.microsoft.com/office/drawing/2014/main" id="{124361B1-5CC0-15F4-89DB-765D1EB739CB}"/>
+              </a:ext>
+            </a:extLst>
+          </p:cNvPr>
+          <p:cNvPicPr>
+            <a:picLocks noChangeAspect="1"/>
+          </p:cNvPicPr>
+          <p:nvPr/>
+        </p:nvPicPr>
+        <p:blipFill>
+          <a:blip r:embed="rId3"/>
+          <a:stretch>
+            <a:fillRect/>
+          </a:stretch>
+        </p:blipFill>
+        <p:spPr>
+          <a:xfrm>
+            <a:off x="653394" y="104542"/>
+            <a:ext cx="1019317" cy="1114581"/>
+          </a:xfrm>
+          <a:prstGeom prst="rect">
+            <a:avLst/>
+          </a:prstGeom>
+        </p:spPr>
+      </p:pic>
+    </p:spTree>
+    <p:extLst>
+      <p:ext uri="{BB962C8B-B14F-4D97-AF65-F5344CB8AC3E}">
+        <p14:creationId xmlns:p14="http://schemas.microsoft.com/office/powerpoint/2010/main" val="457780916"/>
+      </p:ext>
+    </p:extLst>
+  </p:cSld>
+  <p:clrMapOvr>
+    <a:masterClrMapping/>
+  </p:clrMapOvr>
+</p:sld>
+</file>
+
 <file path=ppt/theme/theme1.xml><?xml version="1.0" encoding="utf-8"?>
 <a:theme xmlns:a="http://schemas.openxmlformats.org/drawingml/2006/main" name="Office Theme">
   <a:themeElements>

</xml_diff>